<commit_message>
Submission kit filled from measured results: write-up, tags, slides (PDF) with v2 numbers
Co-Authored-By: Claude Opus 5 <noreply@anthropic.com>
</commit_message>
<xml_diff>
--- a/docs/submission/rescuehands_slides.pptx
+++ b/docs/submission/rescuehands_slides.pptx
@@ -6563,11 +6563,11 @@
                       <a:r>
                         <a:rPr sz="1600" b="1">
                           <a:solidFill>
-                            <a:srgbClr val="FF9F1C"/>
+                            <a:srgbClr val="F2F5F9"/>
                           </a:solidFill>
                           <a:latin typeface="Segoe UI"/>
                         </a:rPr>
-                        <a:t>⟨y⟩/10</a:t>
+                        <a:t>not run</a:t>
                       </a:r>
                     </a:p>
                   </a:txBody>
@@ -6653,11 +6653,11 @@
                       <a:r>
                         <a:rPr sz="1600" b="1">
                           <a:solidFill>
-                            <a:srgbClr val="FF9F1C"/>
+                            <a:srgbClr val="F2F5F9"/>
                           </a:solidFill>
                           <a:latin typeface="Segoe UI"/>
                         </a:rPr>
-                        <a:t>⟨x⟩/10</a:t>
+                        <a:t>not run</a:t>
                       </a:r>
                     </a:p>
                   </a:txBody>
@@ -6743,11 +6743,11 @@
                       <a:r>
                         <a:rPr sz="1600" b="1">
                           <a:solidFill>
-                            <a:srgbClr val="FF9F1C"/>
+                            <a:srgbClr val="F2F5F9"/>
                           </a:solidFill>
                           <a:latin typeface="Segoe UI"/>
                         </a:rPr>
-                        <a:t>⟨w⟩/10</a:t>
+                        <a:t>running</a:t>
                       </a:r>
                     </a:p>
                   </a:txBody>
@@ -6833,11 +6833,11 @@
                       <a:r>
                         <a:rPr sz="1600" b="1">
                           <a:solidFill>
-                            <a:srgbClr val="FF9F1C"/>
+                            <a:srgbClr val="F2F5F9"/>
                           </a:solidFill>
                           <a:latin typeface="Segoe UI"/>
                         </a:rPr>
-                        <a:t>⟨z⟩/10</a:t>
+                        <a:t>1/10</a:t>
                       </a:r>
                     </a:p>
                   </a:txBody>
@@ -7117,11 +7117,11 @@
                       <a:r>
                         <a:rPr sz="1600" b="0">
                           <a:solidFill>
-                            <a:srgbClr val="FF9F1C"/>
+                            <a:srgbClr val="F2F5F9"/>
                           </a:solidFill>
                           <a:latin typeface="Segoe UI"/>
                         </a:rPr>
-                        <a:t>⟨b⟩ s</a:t>
+                        <a:t>≈190 s (v1)</a:t>
                       </a:r>
                     </a:p>
                   </a:txBody>
@@ -7139,11 +7139,11 @@
                       <a:r>
                         <a:rPr sz="1600" b="0">
                           <a:solidFill>
-                            <a:srgbClr val="FF9F1C"/>
+                            <a:srgbClr val="F2F5F9"/>
                           </a:solidFill>
                           <a:latin typeface="Segoe UI"/>
                         </a:rPr>
-                        <a:t>⟨d⟩ rad</a:t>
+                        <a:t>0.004 rad (v1)</a:t>
                       </a:r>
                     </a:p>
                   </a:txBody>
@@ -7185,11 +7185,11 @@
                       <a:r>
                         <a:rPr sz="1600" b="0">
                           <a:solidFill>
-                            <a:srgbClr val="FF9F1C"/>
+                            <a:srgbClr val="F2F5F9"/>
                           </a:solidFill>
                           <a:latin typeface="Segoe UI"/>
                         </a:rPr>
-                        <a:t>⟨e⟩ s</a:t>
+                        <a:t>13.9 s (v1)</a:t>
                       </a:r>
                     </a:p>
                   </a:txBody>
@@ -7253,11 +7253,11 @@
                       <a:r>
                         <a:rPr sz="1600" b="0">
                           <a:solidFill>
-                            <a:srgbClr val="FF9F1C"/>
+                            <a:srgbClr val="F2F5F9"/>
                           </a:solidFill>
                           <a:latin typeface="Segoe UI"/>
                         </a:rPr>
-                        <a:t>⟨a⟩ s</a:t>
+                        <a:t>4.53 s</a:t>
                       </a:r>
                     </a:p>
                   </a:txBody>
@@ -7275,11 +7275,11 @@
                       <a:r>
                         <a:rPr sz="1600" b="0">
                           <a:solidFill>
-                            <a:srgbClr val="FF9F1C"/>
+                            <a:srgbClr val="F2F5F9"/>
                           </a:solidFill>
                           <a:latin typeface="Segoe UI"/>
                         </a:rPr>
-                        <a:t>⟨d⟩ rad</a:t>
+                        <a:t>0.004 rad (v1)</a:t>
                       </a:r>
                     </a:p>
                   </a:txBody>
@@ -7321,11 +7321,11 @@
                       <a:r>
                         <a:rPr sz="1600" b="0">
                           <a:solidFill>
-                            <a:srgbClr val="FF9F1C"/>
+                            <a:srgbClr val="F2F5F9"/>
                           </a:solidFill>
                           <a:latin typeface="Segoe UI"/>
                         </a:rPr>
-                        <a:t>⟨f⟩ s</a:t>
+                        <a:t>not measured</a:t>
                       </a:r>
                     </a:p>
                   </a:txBody>
@@ -7343,11 +7343,11 @@
                       <a:r>
                         <a:rPr sz="1600" b="0">
                           <a:solidFill>
-                            <a:srgbClr val="FF9F1C"/>
+                            <a:srgbClr val="F2F5F9"/>
                           </a:solidFill>
                           <a:latin typeface="Segoe UI"/>
                         </a:rPr>
-                        <a:t>⟨g⟩ rad</a:t>
+                        <a:t>—</a:t>
                       </a:r>
                     </a:p>
                   </a:txBody>
@@ -7392,11 +7392,11 @@
             <a:r>
               <a:rPr sz="1700" b="0">
                 <a:solidFill>
-                  <a:srgbClr val="FF9F1C"/>
+                  <a:srgbClr val="F2F5F9"/>
                 </a:solidFill>
                 <a:latin typeface="Segoe UI"/>
               </a:rPr>
-              <a:t>•  iGPU speed-up over PyTorch CPU: ⟨c⟩×, with its accuracy cost reported next to it</a:t>
+              <a:t>•  iGPU speed-up over PyTorch CPU: ≈40×, with its accuracy cost reported next to it</a:t>
             </a:r>
           </a:p>
           <a:p>

</xml_diff>